<commit_message>
Refined Time Agent UI with header toggle and progress sub-views (#43)
</commit_message>
<xml_diff>
--- a/server/test_fastapi_output.pptx
+++ b/server/test_fastapi_output.pptx
@@ -9,7 +9,7 @@
     <p:sldId id="257" r:id="rId8"/>
     <p:sldId id="258" r:id="rId9"/>
   </p:sldIdLst>
-  <p:sldSz cx="9144000" cy="6858000" type="screen4x3"/>
+  <p:sldSz cx="9144000" cy="5143500" type="screen4x3"/>
   <p:notesSz cx="6858000" cy="9144000"/>
   <p:defaultTextStyle>
     <a:defPPr>
@@ -3086,7 +3086,7 @@
     <p:bg>
       <p:bgPr>
         <a:solidFill>
-          <a:srgbClr val="121212"/>
+          <a:srgbClr val="F0F4F8"/>
         </a:solidFill>
         <a:effectLst/>
       </p:bgPr>
@@ -3106,7 +3106,7 @@
         </p:nvSpPr>
         <p:spPr>
           <a:xfrm>
-            <a:off x="914400" y="2286000"/>
+            <a:off x="914400" y="1645920"/>
             <a:ext cx="7315200" cy="1828800"/>
           </a:xfrm>
           <a:prstGeom prst="rect">
@@ -3115,21 +3115,20 @@
           <a:noFill/>
         </p:spPr>
         <p:txBody>
-          <a:bodyPr wrap="none">
+          <a:bodyPr wrap="square">
             <a:spAutoFit/>
           </a:bodyPr>
           <a:lstStyle/>
           <a:p>
-            <a:pPr algn="ctr">
-              <a:defRPr sz="4400" b="1">
+            <a:pPr algn="ctr"/>
+            <a:r>
+              <a:rPr sz="5800" b="1">
                 <a:solidFill>
-                  <a:srgbClr val="00E5FF"/>
+                  <a:srgbClr val="007BFF"/>
                 </a:solidFill>
-                <a:latin typeface="Century Gothic"/>
-              </a:defRPr>
-            </a:pPr>
-            <a:r>
-              <a:t>AI IS REVOLUTIONIZING HEALTHCARE</a:t>
+                <a:latin typeface="Arial Black"/>
+              </a:rPr>
+              <a:t>THE FUTURE OF AI IN HEALTHCARE</a:t>
             </a:r>
           </a:p>
         </p:txBody>
@@ -3142,8 +3141,8 @@
         </p:nvSpPr>
         <p:spPr>
           <a:xfrm>
-            <a:off x="1828800" y="4572000"/>
-            <a:ext cx="5486400" cy="914400"/>
+            <a:off x="914400" y="2926080"/>
+            <a:ext cx="7315200" cy="914400"/>
           </a:xfrm>
           <a:prstGeom prst="rect">
             <a:avLst/>
@@ -3151,22 +3150,61 @@
           <a:noFill/>
         </p:spPr>
         <p:txBody>
-          <a:bodyPr wrap="none">
+          <a:bodyPr wrap="square">
             <a:spAutoFit/>
           </a:bodyPr>
           <a:lstStyle/>
           <a:p>
-            <a:pPr algn="ctr">
-              <a:defRPr sz="2000" b="0">
+            <a:pPr algn="ctr"/>
+            <a:r>
+              <a:rPr sz="2200" b="0">
                 <a:solidFill>
-                  <a:srgbClr val="FFFFFF"/>
+                  <a:srgbClr val="AAB2BD"/>
                 </a:solidFill>
-                <a:latin typeface="Century Gothic"/>
-              </a:defRPr>
-            </a:pPr>
-            <a:r>
-              <a:t>AI is revolutionizing healthcare, transforming patient outcomes.</a:t>
-            </a:r>
+                <a:latin typeface="Arial"/>
+              </a:rPr>
+              <a:t>Revolutionizing Diagnostics and Personalized Medicine</a:t>
+            </a:r>
+          </a:p>
+        </p:txBody>
+      </p:sp>
+      <p:sp>
+        <p:nvSpPr>
+          <p:cNvPr id="4" name="Rectangle 3"/>
+          <p:cNvSpPr/>
+          <p:nvPr/>
+        </p:nvSpPr>
+        <p:spPr>
+          <a:xfrm>
+            <a:off x="3657600" y="2834640"/>
+            <a:ext cx="1828800" cy="27432"/>
+          </a:xfrm>
+          <a:prstGeom prst="rect">
+            <a:avLst/>
+          </a:prstGeom>
+          <a:solidFill>
+            <a:srgbClr val="007BFF"/>
+          </a:solidFill>
+        </p:spPr>
+        <p:style>
+          <a:lnRef idx="1">
+            <a:schemeClr val="accent1"/>
+          </a:lnRef>
+          <a:fillRef idx="3">
+            <a:schemeClr val="accent1"/>
+          </a:fillRef>
+          <a:effectRef idx="2">
+            <a:schemeClr val="accent1"/>
+          </a:effectRef>
+          <a:fontRef idx="minor">
+            <a:schemeClr val="lt1"/>
+          </a:fontRef>
+        </p:style>
+        <p:txBody>
+          <a:bodyPr rtlCol="0" anchor="ctr"/>
+          <a:lstStyle/>
+          <a:p>
+            <a:pPr algn="ctr"/>
           </a:p>
         </p:txBody>
       </p:sp>
@@ -3184,7 +3222,7 @@
     <p:bg>
       <p:bgPr>
         <a:solidFill>
-          <a:srgbClr val="121212"/>
+          <a:srgbClr val="F0F4F8"/>
         </a:solidFill>
         <a:effectLst/>
       </p:bgPr>
@@ -3205,16 +3243,93 @@
         <p:spPr>
           <a:xfrm>
             <a:off x="0" y="0"/>
-            <a:ext cx="9144000" cy="137160"/>
+            <a:ext cx="36576" cy="5143500"/>
           </a:xfrm>
           <a:prstGeom prst="rect">
             <a:avLst/>
           </a:prstGeom>
           <a:solidFill>
-            <a:srgbClr val="00E5FF"/>
+            <a:srgbClr val="007BFF"/>
           </a:solidFill>
-          <a:ln>
-            <a:noFill/>
+        </p:spPr>
+        <p:style>
+          <a:lnRef idx="1">
+            <a:schemeClr val="accent1"/>
+          </a:lnRef>
+          <a:fillRef idx="3">
+            <a:schemeClr val="accent1"/>
+          </a:fillRef>
+          <a:effectRef idx="2">
+            <a:schemeClr val="accent1"/>
+          </a:effectRef>
+          <a:fontRef idx="minor">
+            <a:schemeClr val="lt1"/>
+          </a:fontRef>
+        </p:style>
+        <p:txBody>
+          <a:bodyPr rtlCol="0" anchor="ctr"/>
+          <a:lstStyle/>
+          <a:p>
+            <a:pPr algn="ctr"/>
+          </a:p>
+        </p:txBody>
+      </p:sp>
+      <p:sp>
+        <p:nvSpPr>
+          <p:cNvPr id="3" name="TextBox 2"/>
+          <p:cNvSpPr txBox="1"/>
+          <p:nvPr/>
+        </p:nvSpPr>
+        <p:spPr>
+          <a:xfrm>
+            <a:off x="548640" y="365760"/>
+            <a:ext cx="8046720" cy="731520"/>
+          </a:xfrm>
+          <a:prstGeom prst="rect">
+            <a:avLst/>
+          </a:prstGeom>
+          <a:noFill/>
+        </p:spPr>
+        <p:txBody>
+          <a:bodyPr wrap="square">
+            <a:spAutoFit/>
+          </a:bodyPr>
+          <a:lstStyle/>
+          <a:p>
+            <a:pPr algn="l"/>
+            <a:r>
+              <a:rPr sz="3400" b="1">
+                <a:solidFill>
+                  <a:srgbClr val="007BFF"/>
+                </a:solidFill>
+                <a:latin typeface="Arial Black"/>
+              </a:rPr>
+              <a:t>AI and Diagnostics</a:t>
+            </a:r>
+          </a:p>
+        </p:txBody>
+      </p:sp>
+      <p:sp>
+        <p:nvSpPr>
+          <p:cNvPr id="4" name="Rounded Rectangle 3"/>
+          <p:cNvSpPr/>
+          <p:nvPr/>
+        </p:nvSpPr>
+        <p:spPr>
+          <a:xfrm>
+            <a:off x="548640" y="1188720"/>
+            <a:ext cx="2560320" cy="3200400"/>
+          </a:xfrm>
+          <a:prstGeom prst="roundRect">
+            <a:avLst/>
+          </a:prstGeom>
+          <a:solidFill>
+            <a:srgbClr val="F0F4F8"/>
+          </a:solidFill>
+          <a:ln w="12700">
+            <a:solidFill>
+              <a:srgbClr val="007BFF"/>
+            </a:solidFill>
           </a:ln>
         </p:spPr>
         <p:style>
@@ -3241,14 +3356,14 @@
       </p:sp>
       <p:sp>
         <p:nvSpPr>
-          <p:cNvPr id="3" name="TextBox 2"/>
+          <p:cNvPr id="5" name="TextBox 4"/>
           <p:cNvSpPr txBox="1"/>
           <p:nvPr/>
         </p:nvSpPr>
         <p:spPr>
           <a:xfrm>
-            <a:off x="457200" y="457200"/>
-            <a:ext cx="8229600" cy="914400"/>
+            <a:off x="640080" y="1280160"/>
+            <a:ext cx="2377439" cy="3017520"/>
           </a:xfrm>
           <a:prstGeom prst="rect">
             <a:avLst/>
@@ -3256,35 +3371,83 @@
           <a:noFill/>
         </p:spPr>
         <p:txBody>
-          <a:bodyPr wrap="none">
+          <a:bodyPr wrap="square">
             <a:spAutoFit/>
           </a:bodyPr>
           <a:lstStyle/>
           <a:p>
             <a:pPr>
-              <a:defRPr sz="3200" b="1">
+              <a:spcBef>
+                <a:spcPts val="800"/>
+              </a:spcBef>
+              <a:defRPr sz="1400">
                 <a:solidFill>
-                  <a:srgbClr val="FFFFFF"/>
+                  <a:srgbClr val="333333"/>
                 </a:solidFill>
-                <a:latin typeface="Century Gothic"/>
+                <a:latin typeface="Arial"/>
               </a:defRPr>
             </a:pPr>
             <a:r>
-              <a:t>CHALLENGES IN HEALTHCARE</a:t>
-            </a:r>
-          </a:p>
-        </p:txBody>
-      </p:sp>
-      <p:sp>
-        <p:nvSpPr>
-          <p:cNvPr id="4" name="TextBox 3"/>
+              <a:t>Enhanced Imaging Analysis</a:t>
+            </a:r>
+          </a:p>
+        </p:txBody>
+      </p:sp>
+      <p:sp>
+        <p:nvSpPr>
+          <p:cNvPr id="6" name="Rounded Rectangle 5"/>
+          <p:cNvSpPr/>
+          <p:nvPr/>
+        </p:nvSpPr>
+        <p:spPr>
+          <a:xfrm>
+            <a:off x="3291840" y="1188720"/>
+            <a:ext cx="2560320" cy="3200400"/>
+          </a:xfrm>
+          <a:prstGeom prst="roundRect">
+            <a:avLst/>
+          </a:prstGeom>
+          <a:solidFill>
+            <a:srgbClr val="F0F4F8"/>
+          </a:solidFill>
+          <a:ln w="12700">
+            <a:solidFill>
+              <a:srgbClr val="007BFF"/>
+            </a:solidFill>
+          </a:ln>
+        </p:spPr>
+        <p:style>
+          <a:lnRef idx="1">
+            <a:schemeClr val="accent1"/>
+          </a:lnRef>
+          <a:fillRef idx="3">
+            <a:schemeClr val="accent1"/>
+          </a:fillRef>
+          <a:effectRef idx="2">
+            <a:schemeClr val="accent1"/>
+          </a:effectRef>
+          <a:fontRef idx="minor">
+            <a:schemeClr val="lt1"/>
+          </a:fontRef>
+        </p:style>
+        <p:txBody>
+          <a:bodyPr rtlCol="0" anchor="ctr"/>
+          <a:lstStyle/>
+          <a:p>
+            <a:pPr algn="ctr"/>
+          </a:p>
+        </p:txBody>
+      </p:sp>
+      <p:sp>
+        <p:nvSpPr>
+          <p:cNvPr id="7" name="TextBox 6"/>
           <p:cNvSpPr txBox="1"/>
           <p:nvPr/>
         </p:nvSpPr>
         <p:spPr>
           <a:xfrm>
-            <a:off x="457200" y="1828800"/>
-            <a:ext cx="4114800" cy="4114800"/>
+            <a:off x="3383280" y="1280160"/>
+            <a:ext cx="2377439" cy="3017520"/>
           </a:xfrm>
           <a:prstGeom prst="rect">
             <a:avLst/>
@@ -3296,73 +3459,150 @@
             <a:spAutoFit/>
           </a:bodyPr>
           <a:lstStyle/>
-          <a:p/>
           <a:p>
             <a:pPr>
-              <a:spcAft>
-                <a:spcPts val="1400"/>
-              </a:spcAft>
-              <a:defRPr sz="1800" b="0">
+              <a:spcBef>
+                <a:spcPts val="800"/>
+              </a:spcBef>
+              <a:defRPr sz="1400">
                 <a:solidFill>
-                  <a:srgbClr val="FFFFFF"/>
+                  <a:srgbClr val="333333"/>
                 </a:solidFill>
-                <a:latin typeface="Century Gothic"/>
+                <a:latin typeface="Arial"/>
               </a:defRPr>
             </a:pPr>
             <a:r>
-              <a:t>• Diagnostic errors lead to a significant number of patient deaths.</a:t>
-            </a:r>
-          </a:p>
+              <a:t>Predictive Analytics for Disease Prevention</a:t>
+            </a:r>
+          </a:p>
+        </p:txBody>
+      </p:sp>
+      <p:sp>
+        <p:nvSpPr>
+          <p:cNvPr id="8" name="Rounded Rectangle 7"/>
+          <p:cNvSpPr/>
+          <p:nvPr/>
+        </p:nvSpPr>
+        <p:spPr>
+          <a:xfrm>
+            <a:off x="6035040" y="1188720"/>
+            <a:ext cx="2560320" cy="3200400"/>
+          </a:xfrm>
+          <a:prstGeom prst="roundRect">
+            <a:avLst/>
+          </a:prstGeom>
+          <a:solidFill>
+            <a:srgbClr val="F0F4F8"/>
+          </a:solidFill>
+          <a:ln w="12700">
+            <a:solidFill>
+              <a:srgbClr val="007BFF"/>
+            </a:solidFill>
+          </a:ln>
+        </p:spPr>
+        <p:style>
+          <a:lnRef idx="1">
+            <a:schemeClr val="accent1"/>
+          </a:lnRef>
+          <a:fillRef idx="3">
+            <a:schemeClr val="accent1"/>
+          </a:fillRef>
+          <a:effectRef idx="2">
+            <a:schemeClr val="accent1"/>
+          </a:effectRef>
+          <a:fontRef idx="minor">
+            <a:schemeClr val="lt1"/>
+          </a:fontRef>
+        </p:style>
+        <p:txBody>
+          <a:bodyPr rtlCol="0" anchor="ctr"/>
+          <a:lstStyle/>
+          <a:p>
+            <a:pPr algn="ctr"/>
+          </a:p>
+        </p:txBody>
+      </p:sp>
+      <p:sp>
+        <p:nvSpPr>
+          <p:cNvPr id="9" name="TextBox 8"/>
+          <p:cNvSpPr txBox="1"/>
+          <p:nvPr/>
+        </p:nvSpPr>
+        <p:spPr>
+          <a:xfrm>
+            <a:off x="6126479" y="1280160"/>
+            <a:ext cx="2377439" cy="3017520"/>
+          </a:xfrm>
+          <a:prstGeom prst="rect">
+            <a:avLst/>
+          </a:prstGeom>
+          <a:noFill/>
+        </p:spPr>
+        <p:txBody>
+          <a:bodyPr wrap="square">
+            <a:spAutoFit/>
+          </a:bodyPr>
+          <a:lstStyle/>
           <a:p>
             <a:pPr>
-              <a:spcAft>
-                <a:spcPts val="1400"/>
-              </a:spcAft>
-              <a:defRPr sz="1800" b="0">
+              <a:spcBef>
+                <a:spcPts val="800"/>
+              </a:spcBef>
+              <a:defRPr sz="1400">
                 <a:solidFill>
-                  <a:srgbClr val="FFFFFF"/>
+                  <a:srgbClr val="333333"/>
                 </a:solidFill>
-                <a:latin typeface="Century Gothic"/>
+                <a:latin typeface="Arial"/>
               </a:defRPr>
             </a:pPr>
             <a:r>
-              <a:t>• One-size-fits-all treatments fail diverse patient needs.</a:t>
-            </a:r>
-          </a:p>
-          <a:p>
-            <a:pPr>
-              <a:spcAft>
-                <a:spcPts val="1400"/>
-              </a:spcAft>
-              <a:defRPr sz="1800" b="0">
-                <a:solidFill>
-                  <a:srgbClr val="FFFFFF"/>
-                </a:solidFill>
-                <a:latin typeface="Century Gothic"/>
-              </a:defRPr>
-            </a:pPr>
-            <a:r>
-              <a:t>• Traditional methods often overlook critical data insights.</a:t>
-            </a:r>
-          </a:p>
-        </p:txBody>
-      </p:sp>
-      <p:sp>
-        <p:nvSpPr>
-          <p:cNvPr id="5" name="Rectangle 4"/>
+              <a:t>Automated Pathology Detection</a:t>
+            </a:r>
+          </a:p>
+        </p:txBody>
+      </p:sp>
+    </p:spTree>
+  </p:cSld>
+  <p:clrMapOvr>
+    <a:masterClrMapping/>
+  </p:clrMapOvr>
+</p:sld>
+</file>
+
+<file path=ppt/slides/slide3.xml><?xml version="1.0" encoding="utf-8"?>
+<p:sld xmlns:a="http://schemas.openxmlformats.org/drawingml/2006/main" xmlns:p="http://schemas.openxmlformats.org/presentationml/2006/main" xmlns:r="http://schemas.openxmlformats.org/officeDocument/2006/relationships">
+  <p:cSld>
+    <p:bg>
+      <p:bgPr>
+        <a:solidFill>
+          <a:srgbClr val="F0F4F8"/>
+        </a:solidFill>
+        <a:effectLst/>
+      </p:bgPr>
+    </p:bg>
+    <p:spTree>
+      <p:nvGrpSpPr>
+        <p:cNvPr id="1" name=""/>
+        <p:cNvGrpSpPr/>
+        <p:nvPr/>
+      </p:nvGrpSpPr>
+      <p:grpSpPr/>
+      <p:sp>
+        <p:nvSpPr>
+          <p:cNvPr id="2" name="Rectangle 1"/>
           <p:cNvSpPr/>
           <p:nvPr/>
         </p:nvSpPr>
         <p:spPr>
           <a:xfrm>
-            <a:off x="5029200" y="1828800"/>
-            <a:ext cx="3657600" cy="4114800"/>
+            <a:off x="0" y="0"/>
+            <a:ext cx="36576" cy="5143500"/>
           </a:xfrm>
           <a:prstGeom prst="rect">
             <a:avLst/>
           </a:prstGeom>
           <a:solidFill>
-            <a:srgbClr val="00E5FF"/>
+            <a:srgbClr val="007BFF"/>
           </a:solidFill>
         </p:spPr>
         <p:style>
@@ -3383,85 +3623,6 @@
           <a:bodyPr rtlCol="0" anchor="ctr"/>
           <a:lstStyle/>
           <a:p>
-            <a:pPr algn="ctr">
-              <a:defRPr sz="2400" b="1">
-                <a:solidFill>
-                  <a:srgbClr val="121212"/>
-                </a:solidFill>
-                <a:latin typeface="Century Gothic"/>
-              </a:defRPr>
-            </a:pPr>
-            <a:r>
-              <a:t>Visual Concept</a:t>
-            </a:r>
-          </a:p>
-        </p:txBody>
-      </p:sp>
-    </p:spTree>
-  </p:cSld>
-  <p:clrMapOvr>
-    <a:masterClrMapping/>
-  </p:clrMapOvr>
-</p:sld>
-</file>
-
-<file path=ppt/slides/slide3.xml><?xml version="1.0" encoding="utf-8"?>
-<p:sld xmlns:a="http://schemas.openxmlformats.org/drawingml/2006/main" xmlns:p="http://schemas.openxmlformats.org/presentationml/2006/main" xmlns:r="http://schemas.openxmlformats.org/officeDocument/2006/relationships">
-  <p:cSld>
-    <p:bg>
-      <p:bgPr>
-        <a:solidFill>
-          <a:srgbClr val="121212"/>
-        </a:solidFill>
-        <a:effectLst/>
-      </p:bgPr>
-    </p:bg>
-    <p:spTree>
-      <p:nvGrpSpPr>
-        <p:cNvPr id="1" name=""/>
-        <p:cNvGrpSpPr/>
-        <p:nvPr/>
-      </p:nvGrpSpPr>
-      <p:grpSpPr/>
-      <p:sp>
-        <p:nvSpPr>
-          <p:cNvPr id="2" name="Rectangle 1"/>
-          <p:cNvSpPr/>
-          <p:nvPr/>
-        </p:nvSpPr>
-        <p:spPr>
-          <a:xfrm>
-            <a:off x="0" y="0"/>
-            <a:ext cx="9144000" cy="137160"/>
-          </a:xfrm>
-          <a:prstGeom prst="rect">
-            <a:avLst/>
-          </a:prstGeom>
-          <a:solidFill>
-            <a:srgbClr val="00E5FF"/>
-          </a:solidFill>
-          <a:ln>
-            <a:noFill/>
-          </a:ln>
-        </p:spPr>
-        <p:style>
-          <a:lnRef idx="1">
-            <a:schemeClr val="accent1"/>
-          </a:lnRef>
-          <a:fillRef idx="3">
-            <a:schemeClr val="accent1"/>
-          </a:fillRef>
-          <a:effectRef idx="2">
-            <a:schemeClr val="accent1"/>
-          </a:effectRef>
-          <a:fontRef idx="minor">
-            <a:schemeClr val="lt1"/>
-          </a:fontRef>
-        </p:style>
-        <p:txBody>
-          <a:bodyPr rtlCol="0" anchor="ctr"/>
-          <a:lstStyle/>
-          <a:p>
             <a:pPr algn="ctr"/>
           </a:p>
         </p:txBody>
@@ -3474,8 +3635,8 @@
         </p:nvSpPr>
         <p:spPr>
           <a:xfrm>
-            <a:off x="457200" y="457200"/>
-            <a:ext cx="8229600" cy="914400"/>
+            <a:off x="548640" y="365760"/>
+            <a:ext cx="8046720" cy="731520"/>
           </a:xfrm>
           <a:prstGeom prst="rect">
             <a:avLst/>
@@ -3483,28 +3644,27 @@
           <a:noFill/>
         </p:spPr>
         <p:txBody>
-          <a:bodyPr wrap="none">
+          <a:bodyPr wrap="square">
             <a:spAutoFit/>
           </a:bodyPr>
           <a:lstStyle/>
           <a:p>
-            <a:pPr>
-              <a:defRPr sz="3200" b="1">
+            <a:pPr algn="l"/>
+            <a:r>
+              <a:rPr sz="3400" b="1">
                 <a:solidFill>
-                  <a:srgbClr val="FFFFFF"/>
+                  <a:srgbClr val="007BFF"/>
                 </a:solidFill>
-                <a:latin typeface="Century Gothic"/>
-              </a:defRPr>
-            </a:pPr>
-            <a:r>
-              <a:t>CORE CONCEPTS OF AI IN HEALTHCARE</a:t>
+                <a:latin typeface="Arial Black"/>
+              </a:rPr>
+              <a:t>Personalized Medicine through AI</a:t>
             </a:r>
           </a:p>
         </p:txBody>
       </p:sp>
       <p:pic>
         <p:nvPicPr>
-          <p:cNvPr id="4" name="Picture 3" descr="tmpwzz4u_b2.png"/>
+          <p:cNvPr id="4" name="Picture 3" descr="image.jpg"/>
           <p:cNvPicPr>
             <a:picLocks noChangeAspect="1"/>
           </p:cNvPicPr>
@@ -3518,8 +3678,8 @@
         </p:blipFill>
         <p:spPr>
           <a:xfrm>
-            <a:off x="457200" y="1828800"/>
-            <a:ext cx="5029200" cy="3657600"/>
+            <a:off x="548640" y="1188720"/>
+            <a:ext cx="2314698" cy="3474720"/>
           </a:xfrm>
           <a:prstGeom prst="rect">
             <a:avLst/>
@@ -3534,8 +3694,8 @@
         </p:nvSpPr>
         <p:spPr>
           <a:xfrm>
-            <a:off x="5669280" y="1828800"/>
-            <a:ext cx="3017520" cy="3657600"/>
+            <a:off x="4754880" y="1188720"/>
+            <a:ext cx="3840480" cy="3474720"/>
           </a:xfrm>
           <a:prstGeom prst="rect">
             <a:avLst/>
@@ -3547,37 +3707,52 @@
             <a:spAutoFit/>
           </a:bodyPr>
           <a:lstStyle/>
-          <a:p/>
           <a:p>
             <a:pPr>
-              <a:spcAft>
-                <a:spcPts val="1400"/>
-              </a:spcAft>
-              <a:defRPr sz="1600" b="0">
+              <a:spcBef>
+                <a:spcPts val="800"/>
+              </a:spcBef>
+              <a:defRPr sz="1800">
                 <a:solidFill>
-                  <a:srgbClr val="FFFFFF"/>
+                  <a:srgbClr val="333333"/>
                 </a:solidFill>
-                <a:latin typeface="Century Gothic"/>
+                <a:latin typeface="Arial"/>
               </a:defRPr>
             </a:pPr>
             <a:r>
-              <a:t>■ Definition of AI in Healthcare: Encompasses machine learning, data analytics, and robotics.</a:t>
+              <a:t>Tailored Treatment Plans</a:t>
             </a:r>
           </a:p>
           <a:p>
             <a:pPr>
-              <a:spcAft>
-                <a:spcPts val="1400"/>
-              </a:spcAft>
-              <a:defRPr sz="1600" b="0">
+              <a:spcBef>
+                <a:spcPts val="800"/>
+              </a:spcBef>
+              <a:defRPr sz="1800">
                 <a:solidFill>
-                  <a:srgbClr val="FFFFFF"/>
+                  <a:srgbClr val="333333"/>
                 </a:solidFill>
-                <a:latin typeface="Century Gothic"/>
+                <a:latin typeface="Arial"/>
               </a:defRPr>
             </a:pPr>
             <a:r>
-              <a:t>■ Key Areas of Impact: Diagnostics and Personalized Medicine.</a:t>
+              <a:t>Genomic Data Analysis</a:t>
+            </a:r>
+          </a:p>
+          <a:p>
+            <a:pPr>
+              <a:spcBef>
+                <a:spcPts val="800"/>
+              </a:spcBef>
+              <a:defRPr sz="1800">
+                <a:solidFill>
+                  <a:srgbClr val="333333"/>
+                </a:solidFill>
+                <a:latin typeface="Arial"/>
+              </a:defRPr>
+            </a:pPr>
+            <a:r>
+              <a:t>Real-time Patient Monitoring</a:t>
             </a:r>
           </a:p>
         </p:txBody>

</xml_diff>